<commit_message>
Update team details: Himanshu (Lead), Team Obsidian
</commit_message>
<xml_diff>
--- a/assets/CardioTwin_Submission_Deck.pptx
+++ b/assets/CardioTwin_Submission_Deck.pptx
@@ -3254,7 +3254,7 @@
               </a:defRPr>
             </a:pPr>
             <a:r>
-              <a:t>Team: Team CardioTwin | Institution / Incubator: Healthcare AI Innovation Lab</a:t>
+              <a:t>Team: Team Obsidian | Lead: Himanshu | Track: Healthcare &amp; Precision Medicine</a:t>
             </a:r>
           </a:p>
           <a:p>
@@ -5240,7 +5240,7 @@
             <a:br/>
             <a:br/>
             <a:r>
-              <a:t>Team: Team CardioTwin | Institution / Incubator: Healthcare AI Innovation Lab</a:t>
+              <a:t>Team: Team Obsidian | Lead: Himanshu | Track: Healthcare &amp; Precision Medicine</a:t>
             </a:r>
             <a:br/>
             <a:r>

</xml_diff>

<commit_message>
Update institution details: Apex Institute of Technology (AIT), Chandigarh University
</commit_message>
<xml_diff>
--- a/assets/CardioTwin_Submission_Deck.pptx
+++ b/assets/CardioTwin_Submission_Deck.pptx
@@ -3254,7 +3254,7 @@
               </a:defRPr>
             </a:pPr>
             <a:r>
-              <a:t>Team: Team Obsidian | Lead: Himanshu | Track: Healthcare &amp; Precision Medicine</a:t>
+              <a:t>Team: Team Obsidian | Lead: Himanshu | Apex Institute of Technology (AIT), Chandigarh University</a:t>
             </a:r>
           </a:p>
           <a:p>
@@ -3266,7 +3266,7 @@
               </a:defRPr>
             </a:pPr>
             <a:r>
-              <a:t>Repository: Public GitHub Repository | Evaluation Track: Healthcare &amp; Precision Medicine</a:t>
+              <a:t>Incubator: CU-TBI Innovation Hub | Repository: Public GitHub | Track: Healthcare &amp; Precision Medicine</a:t>
             </a:r>
           </a:p>
         </p:txBody>
@@ -5240,7 +5240,11 @@
             <a:br/>
             <a:br/>
             <a:r>
-              <a:t>Team: Team Obsidian | Lead: Himanshu | Track: Healthcare &amp; Precision Medicine</a:t>
+              <a:t>Team: Team Obsidian | Lead: Himanshu | Apex Institute of Technology (AIT), Chandigarh University</a:t>
+            </a:r>
+            <a:br/>
+            <a:r>
+              <a:t>Incubator: Chandigarh University Technology Business Incubator (CU-TBI)</a:t>
             </a:r>
             <a:br/>
             <a:r>

</xml_diff>